<commit_message>
Week 4 PowerPoint Updates
</commit_message>
<xml_diff>
--- a/Weekly Reports/Self-Driving-RC-Car.pptx
+++ b/Weekly Reports/Self-Driving-RC-Car.pptx
@@ -261,7 +261,7 @@
           <a:p>
             <a:fld id="{752E6B35-DAD5-CF47-9E65-9CA12B499D8C}" type="datetimeFigureOut">
               <a:rPr lang="en-US" smtClean="0"/>
-              <a:t>9/10/2026</a:t>
+              <a:t>9/14/2026</a:t>
             </a:fld>
             <a:endParaRPr lang="en-US"/>
           </a:p>
@@ -459,7 +459,7 @@
           <a:p>
             <a:fld id="{752E6B35-DAD5-CF47-9E65-9CA12B499D8C}" type="datetimeFigureOut">
               <a:rPr lang="en-US" smtClean="0"/>
-              <a:t>9/10/2026</a:t>
+              <a:t>9/14/2026</a:t>
             </a:fld>
             <a:endParaRPr lang="en-US"/>
           </a:p>
@@ -667,7 +667,7 @@
           <a:p>
             <a:fld id="{752E6B35-DAD5-CF47-9E65-9CA12B499D8C}" type="datetimeFigureOut">
               <a:rPr lang="en-US" smtClean="0"/>
-              <a:t>9/10/2026</a:t>
+              <a:t>9/14/2026</a:t>
             </a:fld>
             <a:endParaRPr lang="en-US"/>
           </a:p>
@@ -865,7 +865,7 @@
           <a:p>
             <a:fld id="{752E6B35-DAD5-CF47-9E65-9CA12B499D8C}" type="datetimeFigureOut">
               <a:rPr lang="en-US" smtClean="0"/>
-              <a:t>9/10/2026</a:t>
+              <a:t>9/14/2026</a:t>
             </a:fld>
             <a:endParaRPr lang="en-US"/>
           </a:p>
@@ -1140,7 +1140,7 @@
           <a:p>
             <a:fld id="{752E6B35-DAD5-CF47-9E65-9CA12B499D8C}" type="datetimeFigureOut">
               <a:rPr lang="en-US" smtClean="0"/>
-              <a:t>9/10/2026</a:t>
+              <a:t>9/14/2026</a:t>
             </a:fld>
             <a:endParaRPr lang="en-US"/>
           </a:p>
@@ -1405,7 +1405,7 @@
           <a:p>
             <a:fld id="{752E6B35-DAD5-CF47-9E65-9CA12B499D8C}" type="datetimeFigureOut">
               <a:rPr lang="en-US" smtClean="0"/>
-              <a:t>9/10/2026</a:t>
+              <a:t>9/14/2026</a:t>
             </a:fld>
             <a:endParaRPr lang="en-US"/>
           </a:p>
@@ -1817,7 +1817,7 @@
           <a:p>
             <a:fld id="{752E6B35-DAD5-CF47-9E65-9CA12B499D8C}" type="datetimeFigureOut">
               <a:rPr lang="en-US" smtClean="0"/>
-              <a:t>9/10/2026</a:t>
+              <a:t>9/14/2026</a:t>
             </a:fld>
             <a:endParaRPr lang="en-US"/>
           </a:p>
@@ -1958,7 +1958,7 @@
           <a:p>
             <a:fld id="{752E6B35-DAD5-CF47-9E65-9CA12B499D8C}" type="datetimeFigureOut">
               <a:rPr lang="en-US" smtClean="0"/>
-              <a:t>9/10/2026</a:t>
+              <a:t>9/14/2026</a:t>
             </a:fld>
             <a:endParaRPr lang="en-US"/>
           </a:p>
@@ -2071,7 +2071,7 @@
           <a:p>
             <a:fld id="{752E6B35-DAD5-CF47-9E65-9CA12B499D8C}" type="datetimeFigureOut">
               <a:rPr lang="en-US" smtClean="0"/>
-              <a:t>9/10/2026</a:t>
+              <a:t>9/14/2026</a:t>
             </a:fld>
             <a:endParaRPr lang="en-US"/>
           </a:p>
@@ -2382,7 +2382,7 @@
           <a:p>
             <a:fld id="{752E6B35-DAD5-CF47-9E65-9CA12B499D8C}" type="datetimeFigureOut">
               <a:rPr lang="en-US" smtClean="0"/>
-              <a:t>9/10/2026</a:t>
+              <a:t>9/14/2026</a:t>
             </a:fld>
             <a:endParaRPr lang="en-US"/>
           </a:p>
@@ -2670,7 +2670,7 @@
           <a:p>
             <a:fld id="{752E6B35-DAD5-CF47-9E65-9CA12B499D8C}" type="datetimeFigureOut">
               <a:rPr lang="en-US" smtClean="0"/>
-              <a:t>9/10/2026</a:t>
+              <a:t>9/14/2026</a:t>
             </a:fld>
             <a:endParaRPr lang="en-US"/>
           </a:p>
@@ -2911,7 +2911,7 @@
           <a:p>
             <a:fld id="{752E6B35-DAD5-CF47-9E65-9CA12B499D8C}" type="datetimeFigureOut">
               <a:rPr lang="en-US" smtClean="0"/>
-              <a:t>9/10/2026</a:t>
+              <a:t>9/14/2026</a:t>
             </a:fld>
             <a:endParaRPr lang="en-US"/>
           </a:p>
@@ -3626,8 +3626,8 @@
           <a:lstStyle/>
           <a:p>
             <a:r>
-              <a:rPr lang="en-US"/>
-              <a:t>Test Slide on Motors</a:t>
+              <a:rPr lang="en-US" dirty="0"/>
+              <a:t>Alexis Perez</a:t>
             </a:r>
           </a:p>
         </p:txBody>
@@ -3650,10 +3650,90 @@
         </p:nvSpPr>
         <p:spPr/>
         <p:txBody>
-          <a:bodyPr/>
-          <a:lstStyle/>
-          <a:p>
-            <a:endParaRPr lang="en-US"/>
+          <a:bodyPr>
+            <a:normAutofit lnSpcReduction="10000"/>
+          </a:bodyPr>
+          <a:lstStyle/>
+          <a:p>
+            <a:r>
+              <a:rPr lang="en-US" b="1" dirty="0"/>
+              <a:t>Goals for the week</a:t>
+            </a:r>
+          </a:p>
+          <a:p>
+            <a:pPr lvl="1"/>
+            <a:r>
+              <a:rPr lang="en-US" dirty="0"/>
+              <a:t>Test Ultrasonic Sensor for Distance, Accuracy, and operational range</a:t>
+            </a:r>
+          </a:p>
+          <a:p>
+            <a:pPr lvl="1"/>
+            <a:r>
+              <a:rPr lang="en-US" dirty="0"/>
+              <a:t>Research Motor options for Vehicle</a:t>
+            </a:r>
+          </a:p>
+          <a:p>
+            <a:r>
+              <a:rPr lang="en-US" b="1" dirty="0"/>
+              <a:t>Progress for the week</a:t>
+            </a:r>
+          </a:p>
+          <a:p>
+            <a:pPr lvl="1"/>
+            <a:r>
+              <a:rPr lang="en-US" dirty="0"/>
+              <a:t>Tested Ultrasonic Sensor’s distance readings and measurement accuracy</a:t>
+            </a:r>
+          </a:p>
+          <a:p>
+            <a:pPr lvl="1"/>
+            <a:r>
+              <a:rPr lang="en-US" dirty="0"/>
+              <a:t>Researched motors for most optimal option for  vehicle</a:t>
+            </a:r>
+          </a:p>
+          <a:p>
+            <a:r>
+              <a:rPr lang="en-US" b="1" dirty="0"/>
+              <a:t>Goals for next week</a:t>
+            </a:r>
+          </a:p>
+          <a:p>
+            <a:pPr lvl="1"/>
+            <a:r>
+              <a:rPr lang="en-US" dirty="0"/>
+              <a:t>Select and Order motors</a:t>
+            </a:r>
+          </a:p>
+          <a:p>
+            <a:pPr lvl="1"/>
+            <a:r>
+              <a:rPr lang="en-US" dirty="0"/>
+              <a:t>Write code to integrate Ultrasonic Sensor onto </a:t>
+            </a:r>
+            <a:r>
+              <a:rPr lang="en-US" dirty="0" err="1"/>
+              <a:t>RaspberryPi</a:t>
+            </a:r>
+            <a:endParaRPr lang="en-US" dirty="0"/>
+          </a:p>
+          <a:p>
+            <a:r>
+              <a:rPr lang="en-US" b="1" dirty="0"/>
+              <a:t>Hours spent on progress</a:t>
+            </a:r>
+          </a:p>
+          <a:p>
+            <a:pPr lvl="1"/>
+            <a:r>
+              <a:rPr lang="en-US" dirty="0"/>
+              <a:t>6 hours.</a:t>
+            </a:r>
+          </a:p>
+          <a:p>
+            <a:endParaRPr lang="en-US" dirty="0"/>
           </a:p>
         </p:txBody>
       </p:sp>

</xml_diff>

<commit_message>
Week 4: merge deck, update parts list and Week 4 report
- Deck: resolve pptx conflict — keep contributor's Alexis Perez slide and
  re-apply Ethan's hardware-purchase bullet to the Ethan Wells slide
- Parts list: add CR2032 RTC battery (Ordered) and motor controller (TBD);
  ultrasonic sensor -> Have; NVMe boot SSD -> Ordered
- Week 4 report: regenerate docx/pdf with Week 4 data (Ethan filled,
  teammates placeholdered)
- build_report.py: fix Weekly Summary heading being blanked (runs identity
  bug); support undated/hourless contribution entries
- context.md: document the Week N/ archive structure and rolling pptx
</commit_message>
<xml_diff>
--- a/Weekly Reports/Self-Driving-RC-Car.pptx
+++ b/Weekly Reports/Self-Driving-RC-Car.pptx
@@ -3490,8 +3490,9 @@
           </a:bodyPr>
           <a:lstStyle/>
           <a:p>
-            <a:r>
-              <a:rPr b="1" dirty="0"/>
+            <a:pPr/>
+            <a:r>
+              <a:rPr b="1"/>
               <a:t>Goals for the week</a:t>
             </a:r>
             <a:endParaRPr lang="en-US" dirty="0"/>
@@ -3499,76 +3500,63 @@
           <a:p>
             <a:pPr lvl="1"/>
             <a:r>
-              <a:rPr dirty="0"/>
               <a:t>Train the traffic-sign model in TensorFlow on the German dataset (GTSRB) and push the training code to the repo.</a:t>
             </a:r>
           </a:p>
           <a:p>
-            <a:r>
-              <a:rPr b="1" dirty="0"/>
+            <a:pPr/>
+            <a:r>
+              <a:rPr b="1"/>
               <a:t>Progress for the week</a:t>
             </a:r>
           </a:p>
           <a:p>
             <a:pPr lvl="1"/>
             <a:r>
-              <a:rPr dirty="0"/>
               <a:t>Trained a CNN on GTSRB, reaching ~95% validation accuracy.</a:t>
             </a:r>
           </a:p>
           <a:p>
             <a:pPr lvl="1"/>
             <a:r>
-              <a:rPr dirty="0"/>
-              <a:t>Committed the trained model (</a:t>
-            </a:r>
-            <a:r>
-              <a:rPr dirty="0" err="1"/>
-              <a:t>gtsrb_model.keras</a:t>
-            </a:r>
-            <a:r>
-              <a:rPr dirty="0"/>
-              <a:t>) and the training script (</a:t>
-            </a:r>
-            <a:r>
-              <a:rPr dirty="0" err="1"/>
-              <a:t>training.py</a:t>
-            </a:r>
-            <a:r>
-              <a:rPr dirty="0"/>
-              <a:t>).</a:t>
+              <a:t>Committed the trained model (gtsrb_model.keras) and the training script (training.py).</a:t>
             </a:r>
           </a:p>
           <a:p>
             <a:pPr lvl="1"/>
             <a:r>
-              <a:rPr dirty="0"/>
               <a:t>Set up a Python 3.12 environment (TensorFlow has no wheels for 3.13/3.14 yet).</a:t>
             </a:r>
           </a:p>
           <a:p>
-            <a:r>
-              <a:rPr b="1" dirty="0"/>
+            <a:pPr lvl="1"/>
+            <a:r>
+              <a:t>Ordered the CR2032 RTC battery and the KIOXIA 128 GB NVMe boot SSD, plus the USB NVMe enclosure to flash it — the enclosure has arrived; the SSD and battery are still in transit.</a:t>
+            </a:r>
+          </a:p>
+          <a:p>
+            <a:pPr/>
+            <a:r>
+              <a:rPr b="1"/>
               <a:t>Goals for next week</a:t>
             </a:r>
           </a:p>
           <a:p>
             <a:pPr lvl="1"/>
             <a:r>
-              <a:rPr dirty="0"/>
               <a:t>Prepare the LISA dataset (US traffic signs) for training.</a:t>
             </a:r>
           </a:p>
           <a:p>
-            <a:r>
-              <a:rPr b="1" dirty="0"/>
+            <a:pPr/>
+            <a:r>
+              <a:rPr b="1"/>
               <a:t>Hours spent on progress</a:t>
             </a:r>
           </a:p>
           <a:p>
             <a:pPr lvl="1"/>
             <a:r>
-              <a:rPr dirty="0"/>
               <a:t>7 hours.</a:t>
             </a:r>
           </a:p>

</xml_diff>

<commit_message>
Week 4 slide updates
</commit_message>
<xml_diff>
--- a/Weekly Reports/Self-Driving-RC-Car.pptx
+++ b/Weekly Reports/Self-Driving-RC-Car.pptx
@@ -8,6 +8,7 @@
     <p:sldId id="256" r:id="rId2"/>
     <p:sldId id="257" r:id="rId3"/>
     <p:sldId id="258" r:id="rId4"/>
+    <p:sldId id="260" r:id="rId5"/>
   </p:sldIdLst>
   <p:sldSz cx="12192000" cy="6858000"/>
   <p:notesSz cx="6858000" cy="9144000"/>
@@ -3486,13 +3487,12 @@
         </p:spPr>
         <p:txBody>
           <a:bodyPr>
-            <a:normAutofit fontScale="92500" lnSpcReduction="10000"/>
+            <a:normAutofit fontScale="85000" lnSpcReduction="20000"/>
           </a:bodyPr>
           <a:lstStyle/>
           <a:p>
-            <a:pPr/>
-            <a:r>
-              <a:rPr b="1"/>
+            <a:r>
+              <a:rPr b="1" dirty="0"/>
               <a:t>Goals for the week</a:t>
             </a:r>
             <a:endParaRPr lang="en-US" dirty="0"/>
@@ -3500,63 +3500,91 @@
           <a:p>
             <a:pPr lvl="1"/>
             <a:r>
+              <a:rPr dirty="0"/>
               <a:t>Train the traffic-sign model in TensorFlow on the German dataset (GTSRB) and push the training code to the repo.</a:t>
             </a:r>
           </a:p>
           <a:p>
-            <a:pPr/>
-            <a:r>
-              <a:rPr b="1"/>
+            <a:r>
+              <a:rPr b="1" dirty="0"/>
               <a:t>Progress for the week</a:t>
             </a:r>
           </a:p>
           <a:p>
             <a:pPr lvl="1"/>
             <a:r>
+              <a:rPr dirty="0"/>
               <a:t>Trained a CNN on GTSRB, reaching ~95% validation accuracy.</a:t>
             </a:r>
           </a:p>
           <a:p>
             <a:pPr lvl="1"/>
             <a:r>
-              <a:t>Committed the trained model (gtsrb_model.keras) and the training script (training.py).</a:t>
+              <a:rPr dirty="0"/>
+              <a:t>Committed the trained model (</a:t>
+            </a:r>
+            <a:r>
+              <a:rPr dirty="0" err="1"/>
+              <a:t>gtsrb_model.keras</a:t>
+            </a:r>
+            <a:r>
+              <a:rPr dirty="0"/>
+              <a:t>) and the training script (training.py).</a:t>
             </a:r>
           </a:p>
           <a:p>
             <a:pPr lvl="1"/>
             <a:r>
+              <a:rPr dirty="0"/>
               <a:t>Set up a Python 3.12 environment (TensorFlow has no wheels for 3.13/3.14 yet).</a:t>
             </a:r>
           </a:p>
           <a:p>
             <a:pPr lvl="1"/>
             <a:r>
-              <a:t>Ordered the CR2032 RTC battery and the KIOXIA 128 GB NVMe boot SSD, plus the USB NVMe enclosure to flash it — the enclosure has arrived; the SSD and battery are still in transit.</a:t>
-            </a:r>
-          </a:p>
-          <a:p>
-            <a:pPr/>
-            <a:r>
-              <a:rPr b="1"/>
+              <a:rPr dirty="0"/>
+              <a:t>Ordered the CR2032 RTC battery and the KIOXIA 128 GB </a:t>
+            </a:r>
+            <a:r>
+              <a:rPr dirty="0" err="1"/>
+              <a:t>NVMe</a:t>
+            </a:r>
+            <a:r>
+              <a:rPr dirty="0"/>
+              <a:t> boot SSD, plus the USB </a:t>
+            </a:r>
+            <a:r>
+              <a:rPr dirty="0" err="1"/>
+              <a:t>NVMe</a:t>
+            </a:r>
+            <a:r>
+              <a:rPr dirty="0"/>
+              <a:t> enclosure to flash it — the enclosure has arrived; the SSD and battery are still in transit.</a:t>
+            </a:r>
+          </a:p>
+          <a:p>
+            <a:r>
+              <a:rPr b="1" dirty="0"/>
               <a:t>Goals for next week</a:t>
             </a:r>
           </a:p>
           <a:p>
             <a:pPr lvl="1"/>
             <a:r>
+              <a:rPr dirty="0"/>
               <a:t>Prepare the LISA dataset (US traffic signs) for training.</a:t>
             </a:r>
           </a:p>
           <a:p>
-            <a:pPr/>
-            <a:r>
-              <a:rPr b="1"/>
+            <a:r>
+              <a:rPr b="1" dirty="0"/>
               <a:t>Hours spent on progress</a:t>
             </a:r>
           </a:p>
           <a:p>
             <a:pPr lvl="1"/>
             <a:r>
+              <a:rPr dirty="0"/>
               <a:t>7 hours.</a:t>
             </a:r>
           </a:p>
@@ -3729,6 +3757,204 @@
     <p:extLst>
       <p:ext uri="{BB962C8B-B14F-4D97-AF65-F5344CB8AC3E}">
         <p14:creationId xmlns:p14="http://schemas.microsoft.com/office/powerpoint/2010/main" val="3566922106"/>
+      </p:ext>
+    </p:extLst>
+  </p:cSld>
+  <p:clrMapOvr>
+    <a:masterClrMapping/>
+  </p:clrMapOvr>
+</p:sld>
+</file>
+
+<file path=ppt/slides/slide4.xml><?xml version="1.0" encoding="utf-8"?>
+<p:sld xmlns:a="http://schemas.openxmlformats.org/drawingml/2006/main" xmlns:r="http://schemas.openxmlformats.org/officeDocument/2006/relationships" xmlns:p="http://schemas.openxmlformats.org/presentationml/2006/main">
+  <p:cSld>
+    <p:spTree>
+      <p:nvGrpSpPr>
+        <p:cNvPr id="1" name="">
+          <a:extLst>
+            <a:ext uri="{FF2B5EF4-FFF2-40B4-BE49-F238E27FC236}">
+              <a16:creationId xmlns:a16="http://schemas.microsoft.com/office/drawing/2014/main" id="{40461179-12E8-72E0-11E2-D91A146F4F17}"/>
+            </a:ext>
+          </a:extLst>
+        </p:cNvPr>
+        <p:cNvGrpSpPr/>
+        <p:nvPr/>
+      </p:nvGrpSpPr>
+      <p:grpSpPr>
+        <a:xfrm>
+          <a:off x="0" y="0"/>
+          <a:ext cx="0" cy="0"/>
+          <a:chOff x="0" y="0"/>
+          <a:chExt cx="0" cy="0"/>
+        </a:xfrm>
+      </p:grpSpPr>
+      <p:sp>
+        <p:nvSpPr>
+          <p:cNvPr id="2" name="Title 1">
+            <a:extLst>
+              <a:ext uri="{FF2B5EF4-FFF2-40B4-BE49-F238E27FC236}">
+                <a16:creationId xmlns:a16="http://schemas.microsoft.com/office/drawing/2014/main" id="{7424A086-AE83-6431-D3A6-AD69F5E4DA99}"/>
+              </a:ext>
+            </a:extLst>
+          </p:cNvPr>
+          <p:cNvSpPr>
+            <a:spLocks noGrp="1"/>
+          </p:cNvSpPr>
+          <p:nvPr>
+            <p:ph type="title"/>
+          </p:nvPr>
+        </p:nvSpPr>
+        <p:spPr/>
+        <p:txBody>
+          <a:bodyPr/>
+          <a:lstStyle/>
+          <a:p>
+            <a:r>
+              <a:rPr lang="en-US" dirty="0"/>
+              <a:t>Ethan Bishop</a:t>
+            </a:r>
+          </a:p>
+        </p:txBody>
+      </p:sp>
+      <p:sp>
+        <p:nvSpPr>
+          <p:cNvPr id="3" name="Content Placeholder 2">
+            <a:extLst>
+              <a:ext uri="{FF2B5EF4-FFF2-40B4-BE49-F238E27FC236}">
+                <a16:creationId xmlns:a16="http://schemas.microsoft.com/office/drawing/2014/main" id="{E21CE5BE-C8C4-DF75-0622-1767719853DF}"/>
+              </a:ext>
+            </a:extLst>
+          </p:cNvPr>
+          <p:cNvSpPr>
+            <a:spLocks noGrp="1"/>
+          </p:cNvSpPr>
+          <p:nvPr>
+            <p:ph idx="1"/>
+          </p:nvPr>
+        </p:nvSpPr>
+        <p:spPr>
+          <a:xfrm>
+            <a:off x="838200" y="1580298"/>
+            <a:ext cx="10515600" cy="4299294"/>
+          </a:xfrm>
+        </p:spPr>
+        <p:txBody>
+          <a:bodyPr>
+            <a:normAutofit fontScale="92500" lnSpcReduction="20000"/>
+          </a:bodyPr>
+          <a:lstStyle/>
+          <a:p>
+            <a:r>
+              <a:rPr b="1" dirty="0"/>
+              <a:t>Goals for the week</a:t>
+            </a:r>
+            <a:endParaRPr lang="en-US" dirty="0"/>
+          </a:p>
+          <a:p>
+            <a:pPr lvl="1"/>
+            <a:r>
+              <a:rPr lang="en-US" dirty="0"/>
+              <a:t>Test IMU for Accuracy</a:t>
+            </a:r>
+          </a:p>
+          <a:p>
+            <a:pPr lvl="1"/>
+            <a:r>
+              <a:rPr lang="en-US" dirty="0"/>
+              <a:t>Research Motor Controller options</a:t>
+            </a:r>
+          </a:p>
+          <a:p>
+            <a:pPr lvl="1"/>
+            <a:r>
+              <a:rPr lang="en-US" dirty="0"/>
+              <a:t>Set up home 3D printer to test chassis components</a:t>
+            </a:r>
+          </a:p>
+          <a:p>
+            <a:r>
+              <a:rPr b="1" dirty="0"/>
+              <a:t>Progress for the week</a:t>
+            </a:r>
+          </a:p>
+          <a:p>
+            <a:pPr lvl="1"/>
+            <a:r>
+              <a:rPr lang="en-US" dirty="0"/>
+              <a:t>Tested IMU for measurement accuracy</a:t>
+            </a:r>
+          </a:p>
+          <a:p>
+            <a:pPr lvl="1"/>
+            <a:r>
+              <a:rPr lang="en-US" dirty="0"/>
+              <a:t>Researched Motor Controller for most optimal option</a:t>
+            </a:r>
+          </a:p>
+          <a:p>
+            <a:pPr lvl="1"/>
+            <a:r>
+              <a:rPr lang="en-US" dirty="0"/>
+              <a:t>Drying out filament for chassis component testing</a:t>
+            </a:r>
+          </a:p>
+          <a:p>
+            <a:r>
+              <a:rPr b="1" dirty="0"/>
+              <a:t>Goals for next week</a:t>
+            </a:r>
+          </a:p>
+          <a:p>
+            <a:pPr lvl="1"/>
+            <a:r>
+              <a:rPr lang="en-US" dirty="0"/>
+              <a:t>Select and </a:t>
+            </a:r>
+            <a:r>
+              <a:rPr lang="en-US"/>
+              <a:t>order Motor </a:t>
+            </a:r>
+            <a:r>
+              <a:rPr lang="en-US" dirty="0"/>
+              <a:t>Controller</a:t>
+            </a:r>
+          </a:p>
+          <a:p>
+            <a:pPr lvl="1"/>
+            <a:r>
+              <a:rPr lang="en-US" dirty="0"/>
+              <a:t>Write code to integrate IMU onto </a:t>
+            </a:r>
+            <a:r>
+              <a:rPr lang="en-US" dirty="0" err="1"/>
+              <a:t>RaspberryPi</a:t>
+            </a:r>
+            <a:endParaRPr lang="en-US" dirty="0"/>
+          </a:p>
+          <a:p>
+            <a:r>
+              <a:rPr b="1" dirty="0"/>
+              <a:t>Hours spent on progress</a:t>
+            </a:r>
+          </a:p>
+          <a:p>
+            <a:pPr lvl="1"/>
+            <a:r>
+              <a:rPr lang="en-US" dirty="0"/>
+              <a:t>6</a:t>
+            </a:r>
+            <a:r>
+              <a:rPr dirty="0"/>
+              <a:t> hours.</a:t>
+            </a:r>
+          </a:p>
+        </p:txBody>
+      </p:sp>
+    </p:spTree>
+    <p:extLst>
+      <p:ext uri="{BB962C8B-B14F-4D97-AF65-F5344CB8AC3E}">
+        <p14:creationId xmlns:p14="http://schemas.microsoft.com/office/powerpoint/2010/main" val="2701754284"/>
       </p:ext>
     </p:extLst>
   </p:cSld>

</xml_diff>

<commit_message>
Per-person slide workflow to avoid pptx merge conflicts
Each member now edits their own file in Weekly Reports/slides/ (one .pptx per
person); assemble_deck.py stitches them, in filename order, into the final
Self-Driving-RC-Car.pptx. No two people touch the same binary, so git no longer
hits unmergeable .pptx conflicts.

- slides/: seeded per-person files (Bishop's real Week 4 content included;
  Abigail is a fill-in placeholder)
- assemble_deck.py: rebuilds the final deck from slides/
- slides/README.md: the team workflow (edit only your own file; run
  assemble_deck.py before submission)
- Self-Driving-RC-Car.pptx: regenerated (adds Abigail's placeholder slide)
</commit_message>
<xml_diff>
--- a/Weekly Reports/Self-Driving-RC-Car.pptx
+++ b/Weekly Reports/Self-Driving-RC-Car.pptx
@@ -5,10 +5,11 @@
     <p:sldMasterId id="2147483648" r:id="rId1"/>
   </p:sldMasterIdLst>
   <p:sldIdLst>
-    <p:sldId id="256" r:id="rId2"/>
-    <p:sldId id="257" r:id="rId3"/>
-    <p:sldId id="258" r:id="rId4"/>
-    <p:sldId id="260" r:id="rId5"/>
+    <p:sldId id="256" r:id="rId5"/>
+    <p:sldId id="257" r:id="rId4"/>
+    <p:sldId id="258" r:id="rId3"/>
+    <p:sldId id="259" r:id="rId2"/>
+    <p:sldId id="260" r:id="rId10"/>
   </p:sldIdLst>
   <p:sldSz cx="12192000" cy="6858000"/>
   <p:notesSz cx="6858000" cy="9144000"/>
@@ -3313,7 +3314,7 @@
 </file>
 
 <file path=ppt/slides/slide1.xml><?xml version="1.0" encoding="utf-8"?>
-<p:sld xmlns:a="http://schemas.openxmlformats.org/drawingml/2006/main" xmlns:r="http://schemas.openxmlformats.org/officeDocument/2006/relationships" xmlns:p="http://schemas.openxmlformats.org/presentationml/2006/main">
+<p:sld xmlns:a="http://schemas.openxmlformats.org/drawingml/2006/main" xmlns:p="http://schemas.openxmlformats.org/presentationml/2006/main" xmlns:r="http://schemas.openxmlformats.org/officeDocument/2006/relationships">
   <p:cSld>
     <p:spTree>
       <p:nvGrpSpPr>
@@ -3321,14 +3322,7 @@
         <p:cNvGrpSpPr/>
         <p:nvPr/>
       </p:nvGrpSpPr>
-      <p:grpSpPr>
-        <a:xfrm>
-          <a:off x="0" y="0"/>
-          <a:ext cx="0" cy="0"/>
-          <a:chOff x="0" y="0"/>
-          <a:chExt cx="0" cy="0"/>
-        </a:xfrm>
-      </p:grpSpPr>
+      <p:grpSpPr/>
       <p:sp>
         <p:nvSpPr>
           <p:cNvPr id="2" name="Title 1">
@@ -3406,11 +3400,6 @@
         </p:txBody>
       </p:sp>
     </p:spTree>
-    <p:extLst>
-      <p:ext uri="{BB962C8B-B14F-4D97-AF65-F5344CB8AC3E}">
-        <p14:creationId xmlns:p14="http://schemas.microsoft.com/office/powerpoint/2010/main" val="2087002903"/>
-      </p:ext>
-    </p:extLst>
   </p:cSld>
   <p:clrMapOvr>
     <a:masterClrMapping/>
@@ -3419,7 +3408,7 @@
 </file>
 
 <file path=ppt/slides/slide2.xml><?xml version="1.0" encoding="utf-8"?>
-<p:sld xmlns:a="http://schemas.openxmlformats.org/drawingml/2006/main" xmlns:r="http://schemas.openxmlformats.org/officeDocument/2006/relationships" xmlns:p="http://schemas.openxmlformats.org/presentationml/2006/main">
+<p:sld xmlns:a="http://schemas.openxmlformats.org/drawingml/2006/main" xmlns:p="http://schemas.openxmlformats.org/presentationml/2006/main" xmlns:r="http://schemas.openxmlformats.org/officeDocument/2006/relationships">
   <p:cSld>
     <p:spTree>
       <p:nvGrpSpPr>
@@ -3427,14 +3416,7 @@
         <p:cNvGrpSpPr/>
         <p:nvPr/>
       </p:nvGrpSpPr>
-      <p:grpSpPr>
-        <a:xfrm>
-          <a:off x="0" y="0"/>
-          <a:ext cx="0" cy="0"/>
-          <a:chOff x="0" y="0"/>
-          <a:chExt cx="0" cy="0"/>
-        </a:xfrm>
-      </p:grpSpPr>
+      <p:grpSpPr/>
       <p:sp>
         <p:nvSpPr>
           <p:cNvPr id="2" name="Title 1">
@@ -3591,11 +3573,6 @@
         </p:txBody>
       </p:sp>
     </p:spTree>
-    <p:extLst>
-      <p:ext uri="{BB962C8B-B14F-4D97-AF65-F5344CB8AC3E}">
-        <p14:creationId xmlns:p14="http://schemas.microsoft.com/office/powerpoint/2010/main" val="2943549623"/>
-      </p:ext>
-    </p:extLst>
   </p:cSld>
   <p:clrMapOvr>
     <a:masterClrMapping/>
@@ -3604,7 +3581,7 @@
 </file>
 
 <file path=ppt/slides/slide3.xml><?xml version="1.0" encoding="utf-8"?>
-<p:sld xmlns:a="http://schemas.openxmlformats.org/drawingml/2006/main" xmlns:r="http://schemas.openxmlformats.org/officeDocument/2006/relationships" xmlns:p="http://schemas.openxmlformats.org/presentationml/2006/main">
+<p:sld xmlns:a="http://schemas.openxmlformats.org/drawingml/2006/main" xmlns:p="http://schemas.openxmlformats.org/presentationml/2006/main" xmlns:r="http://schemas.openxmlformats.org/officeDocument/2006/relationships">
   <p:cSld>
     <p:spTree>
       <p:nvGrpSpPr>
@@ -3612,14 +3589,7 @@
         <p:cNvGrpSpPr/>
         <p:nvPr/>
       </p:nvGrpSpPr>
-      <p:grpSpPr>
-        <a:xfrm>
-          <a:off x="0" y="0"/>
-          <a:ext cx="0" cy="0"/>
-          <a:chOff x="0" y="0"/>
-          <a:chExt cx="0" cy="0"/>
-        </a:xfrm>
-      </p:grpSpPr>
+      <p:grpSpPr/>
       <p:sp>
         <p:nvSpPr>
           <p:cNvPr id="2" name="Title 1">
@@ -3754,11 +3724,6 @@
         </p:txBody>
       </p:sp>
     </p:spTree>
-    <p:extLst>
-      <p:ext uri="{BB962C8B-B14F-4D97-AF65-F5344CB8AC3E}">
-        <p14:creationId xmlns:p14="http://schemas.microsoft.com/office/powerpoint/2010/main" val="3566922106"/>
-      </p:ext>
-    </p:extLst>
   </p:cSld>
   <p:clrMapOvr>
     <a:masterClrMapping/>
@@ -3767,28 +3732,15 @@
 </file>
 
 <file path=ppt/slides/slide4.xml><?xml version="1.0" encoding="utf-8"?>
-<p:sld xmlns:a="http://schemas.openxmlformats.org/drawingml/2006/main" xmlns:r="http://schemas.openxmlformats.org/officeDocument/2006/relationships" xmlns:p="http://schemas.openxmlformats.org/presentationml/2006/main">
+<p:sld xmlns:a="http://schemas.openxmlformats.org/drawingml/2006/main" xmlns:p="http://schemas.openxmlformats.org/presentationml/2006/main" xmlns:r="http://schemas.openxmlformats.org/officeDocument/2006/relationships">
   <p:cSld>
     <p:spTree>
       <p:nvGrpSpPr>
-        <p:cNvPr id="1" name="">
-          <a:extLst>
-            <a:ext uri="{FF2B5EF4-FFF2-40B4-BE49-F238E27FC236}">
-              <a16:creationId xmlns:a16="http://schemas.microsoft.com/office/drawing/2014/main" id="{40461179-12E8-72E0-11E2-D91A146F4F17}"/>
-            </a:ext>
-          </a:extLst>
-        </p:cNvPr>
+        <p:cNvPr id="1" name=""/>
         <p:cNvGrpSpPr/>
         <p:nvPr/>
       </p:nvGrpSpPr>
-      <p:grpSpPr>
-        <a:xfrm>
-          <a:off x="0" y="0"/>
-          <a:ext cx="0" cy="0"/>
-          <a:chOff x="0" y="0"/>
-          <a:chExt cx="0" cy="0"/>
-        </a:xfrm>
-      </p:grpSpPr>
+      <p:grpSpPr/>
       <p:sp>
         <p:nvSpPr>
           <p:cNvPr id="2" name="Title 1">
@@ -3952,11 +3904,133 @@
         </p:txBody>
       </p:sp>
     </p:spTree>
-    <p:extLst>
-      <p:ext uri="{BB962C8B-B14F-4D97-AF65-F5344CB8AC3E}">
-        <p14:creationId xmlns:p14="http://schemas.microsoft.com/office/powerpoint/2010/main" val="2701754284"/>
-      </p:ext>
-    </p:extLst>
+  </p:cSld>
+  <p:clrMapOvr>
+    <a:masterClrMapping/>
+  </p:clrMapOvr>
+</p:sld>
+</file>
+
+<file path=ppt/slides/slide5.xml><?xml version="1.0" encoding="utf-8"?>
+<p:sld xmlns:a="http://schemas.openxmlformats.org/drawingml/2006/main" xmlns:p="http://schemas.openxmlformats.org/presentationml/2006/main" xmlns:r="http://schemas.openxmlformats.org/officeDocument/2006/relationships">
+  <p:cSld>
+    <p:spTree>
+      <p:nvGrpSpPr>
+        <p:cNvPr id="1" name=""/>
+        <p:cNvGrpSpPr/>
+        <p:nvPr/>
+      </p:nvGrpSpPr>
+      <p:grpSpPr/>
+      <p:sp>
+        <p:nvSpPr>
+          <p:cNvPr id="2" name="Title 1">
+            <a:extLst>
+              <a:ext uri="{FF2B5EF4-FFF2-40B4-BE49-F238E27FC236}">
+                <a16:creationId xmlns:a16="http://schemas.microsoft.com/office/drawing/2014/main" id="{6D259182-6FD3-6E62-0AC1-D7F9A089FCBC}"/>
+              </a:ext>
+            </a:extLst>
+          </p:cNvPr>
+          <p:cNvSpPr>
+            <a:spLocks noGrp="1"/>
+          </p:cNvSpPr>
+          <p:nvPr>
+            <p:ph type="title"/>
+          </p:nvPr>
+        </p:nvSpPr>
+        <p:spPr/>
+        <p:txBody>
+          <a:bodyPr/>
+          <a:lstStyle/>
+          <a:p>
+            <a:r>
+              <a:t>Abigail Duran</a:t>
+            </a:r>
+          </a:p>
+        </p:txBody>
+      </p:sp>
+      <p:sp>
+        <p:nvSpPr>
+          <p:cNvPr id="3" name="Content Placeholder 2">
+            <a:extLst>
+              <a:ext uri="{FF2B5EF4-FFF2-40B4-BE49-F238E27FC236}">
+                <a16:creationId xmlns:a16="http://schemas.microsoft.com/office/drawing/2014/main" id="{A7A8531B-14FC-040D-A94D-6293C4D3F000}"/>
+              </a:ext>
+            </a:extLst>
+          </p:cNvPr>
+          <p:cNvSpPr>
+            <a:spLocks noGrp="1"/>
+          </p:cNvSpPr>
+          <p:nvPr>
+            <p:ph idx="1"/>
+          </p:nvPr>
+        </p:nvSpPr>
+        <p:spPr>
+          <a:xfrm>
+            <a:off x="838200" y="1580298"/>
+            <a:ext cx="10515600" cy="4351338"/>
+          </a:xfrm>
+        </p:spPr>
+        <p:txBody>
+          <a:bodyPr>
+            <a:normAutofit fontScale="85000" lnSpcReduction="20000"/>
+          </a:bodyPr>
+          <a:lstStyle/>
+          <a:p>
+            <a:pPr/>
+            <a:r>
+              <a:rPr b="1"/>
+              <a:t>Goals for the week</a:t>
+            </a:r>
+            <a:endParaRPr lang="en-US" dirty="0"/>
+          </a:p>
+          <a:p>
+            <a:pPr lvl="1"/>
+            <a:r>
+              <a:t/>
+            </a:r>
+          </a:p>
+          <a:p>
+            <a:pPr/>
+            <a:r>
+              <a:rPr b="1"/>
+              <a:t>Progress for the week</a:t>
+            </a:r>
+          </a:p>
+          <a:p>
+            <a:pPr lvl="1"/>
+            <a:r>
+              <a:t/>
+            </a:r>
+          </a:p>
+          <a:p>
+            <a:pPr/>
+            <a:r>
+              <a:rPr b="1"/>
+              <a:t>Goals for next week</a:t>
+            </a:r>
+          </a:p>
+          <a:p>
+            <a:pPr lvl="1"/>
+            <a:r>
+              <a:t/>
+            </a:r>
+          </a:p>
+          <a:p>
+            <a:pPr/>
+            <a:r>
+              <a:rPr b="1"/>
+              <a:t>Hours spent on progress</a:t>
+            </a:r>
+          </a:p>
+          <a:p>
+            <a:pPr lvl="1"/>
+            <a:r>
+              <a:t/>
+            </a:r>
+          </a:p>
+        </p:txBody>
+      </p:sp>
+    </p:spTree>
   </p:cSld>
   <p:clrMapOvr>
     <a:masterClrMapping/>

</xml_diff>

<commit_message>
Assemble Week 4 deck and archive to Week 4/
</commit_message>
<xml_diff>
--- a/Weekly Reports/Self-Driving-RC-Car.pptx
+++ b/Weekly Reports/Self-Driving-RC-Car.pptx
@@ -3972,61 +3972,119 @@
         </p:spPr>
         <p:txBody>
           <a:bodyPr>
-            <a:normAutofit fontScale="85000" lnSpcReduction="20000"/>
+            <a:normAutofit fontScale="62500" lnSpcReduction="20000"/>
           </a:bodyPr>
           <a:lstStyle/>
           <a:p>
-            <a:pPr/>
-            <a:r>
-              <a:rPr b="1"/>
+            <a:r>
+              <a:rPr b="1" dirty="0"/>
               <a:t>Goals for the week</a:t>
             </a:r>
+            <a:endParaRPr lang="en-US" b="1" dirty="0"/>
+          </a:p>
+          <a:p>
+            <a:pPr lvl="1"/>
+            <a:r>
+              <a:rPr lang="en-US" dirty="0"/>
+              <a:t>Finalize the list of PCB requirements for the stationary testing system.​</a:t>
+            </a:r>
+          </a:p>
+          <a:p>
+            <a:pPr lvl="1"/>
+            <a:r>
+              <a:rPr lang="en-US" dirty="0"/>
+              <a:t>Determine the major components, connections, and power requirements needed for PCB design.​</a:t>
+            </a:r>
+          </a:p>
+          <a:p>
+            <a:pPr lvl="1"/>
             <a:endParaRPr lang="en-US" dirty="0"/>
           </a:p>
           <a:p>
-            <a:pPr lvl="1"/>
-            <a:r>
-              <a:t/>
-            </a:r>
-          </a:p>
-          <a:p>
-            <a:pPr/>
-            <a:r>
-              <a:rPr b="1"/>
+            <a:r>
+              <a:rPr b="1" dirty="0"/>
               <a:t>Progress for the week</a:t>
             </a:r>
           </a:p>
           <a:p>
             <a:pPr lvl="1"/>
             <a:r>
-              <a:t/>
-            </a:r>
-          </a:p>
-          <a:p>
-            <a:pPr/>
-            <a:r>
-              <a:rPr b="1"/>
+              <a:rPr lang="en-US" dirty="0"/>
+              <a:t>Completed the first-semester schematic for stationary testing of the autonomous car system.​</a:t>
+            </a:r>
+          </a:p>
+          <a:p>
+            <a:pPr lvl="1"/>
+            <a:r>
+              <a:rPr lang="en-US" dirty="0"/>
+              <a:t>Built and refined the schematic around the Raspberry Pi Compute Module 5.​</a:t>
+            </a:r>
+          </a:p>
+          <a:p>
+            <a:pPr lvl="1"/>
+            <a:r>
+              <a:rPr lang="en-US" dirty="0"/>
+              <a:t>Resolved schematic/ERC issues and prepared the design for PCB development.​</a:t>
+            </a:r>
+          </a:p>
+          <a:p>
+            <a:pPr lvl="1"/>
+            <a:r>
+              <a:rPr lang="en-US" dirty="0"/>
+              <a:t>Began hardware prototyping for the stationary testing setup.​</a:t>
+            </a:r>
+          </a:p>
+          <a:p>
+            <a:pPr lvl="1"/>
+            <a:endParaRPr b="1" dirty="0"/>
+          </a:p>
+          <a:p>
+            <a:r>
+              <a:rPr b="1" dirty="0"/>
               <a:t>Goals for next week</a:t>
             </a:r>
           </a:p>
           <a:p>
             <a:pPr lvl="1"/>
             <a:r>
-              <a:t/>
-            </a:r>
-          </a:p>
-          <a:p>
-            <a:pPr/>
-            <a:r>
-              <a:rPr b="1"/>
+              <a:rPr lang="en-US" dirty="0"/>
+              <a:t>Begin the PCB design and layout using the completed schematic.​</a:t>
+            </a:r>
+          </a:p>
+          <a:p>
+            <a:pPr lvl="1"/>
+            <a:r>
+              <a:rPr lang="en-US" dirty="0"/>
+              <a:t>Start placing major components and determining board dimensions.​</a:t>
+            </a:r>
+          </a:p>
+          <a:p>
+            <a:pPr lvl="1"/>
+            <a:r>
+              <a:rPr lang="en-US" dirty="0"/>
+              <a:t>Begin planning power and signal routing.​</a:t>
+            </a:r>
+          </a:p>
+          <a:p>
+            <a:pPr lvl="1"/>
+            <a:endParaRPr b="1" dirty="0"/>
+          </a:p>
+          <a:p>
+            <a:r>
+              <a:rPr b="1" dirty="0"/>
               <a:t>Hours spent on progress</a:t>
             </a:r>
           </a:p>
           <a:p>
             <a:pPr lvl="1"/>
             <a:r>
-              <a:t/>
-            </a:r>
+              <a:rPr lang="en-US" dirty="0"/>
+              <a:t>6 hours​</a:t>
+            </a:r>
+          </a:p>
+          <a:p>
+            <a:pPr lvl="1"/>
+            <a:endParaRPr b="1" dirty="0"/>
           </a:p>
         </p:txBody>
       </p:sp>

</xml_diff>

<commit_message>
Week 4 report with all members; archive to Week 4/
</commit_message>
<xml_diff>
--- a/Weekly Reports/Self-Driving-RC-Car.pptx
+++ b/Weekly Reports/Self-Driving-RC-Car.pptx
@@ -3555,6 +3555,13 @@
             <a:r>
               <a:rPr dirty="0"/>
               <a:t>Prepare the LISA dataset (US traffic signs) for training.</a:t>
+            </a:r>
+          </a:p>
+          <a:p>
+            <a:pPr lvl="1"/>
+            <a:r>
+              <a:rPr dirty="0"/>
+              <a:t>Test the trained German-sign (GTSRB) model.</a:t>
             </a:r>
           </a:p>
           <a:p>

</xml_diff>